<commit_message>
added Microsoft Foundry Copilot Harness Prompt Agents.pptx, updated -Foundry-Whats-New, updated skills
</commit_message>
<xml_diff>
--- a/decks/Microsoft Foundry Guardrails - Tuning Without Over-Blocking.pptx
+++ b/decks/Microsoft Foundry Guardrails - Tuning Without Over-Blocking.pptx
@@ -139,6 +139,14 @@
 </p:presentation>
 </file>
 
+<file path=ppt/revisionInfo.xml><?xml version="1.0" encoding="utf-8"?>
+<p1510:revInfo xmlns:a="http://schemas.openxmlformats.org/drawingml/2006/main" xmlns:r="http://schemas.openxmlformats.org/officeDocument/2006/relationships" xmlns:p1510="http://schemas.microsoft.com/office/powerpoint/2015/10/main">
+  <p1510:revLst>
+    <p1510:client id="{9F2E0053-6AD3-4BB1-B286-6F91667728FA}" v="2" dt="2026-10-30T08:18:09.535"/>
+  </p1510:revLst>
+</p1510:revInfo>
+</file>
+
 <file path=ppt/changesInfos/changesInfo1.xml><?xml version="1.0" encoding="utf-8"?>
 <pc:chgInfo xmlns:a="http://schemas.openxmlformats.org/drawingml/2006/main" xmlns:r="http://schemas.openxmlformats.org/officeDocument/2006/relationships" xmlns:ac="http://schemas.microsoft.com/office/drawing/2013/main/command" xmlns:pc="http://schemas.microsoft.com/office/powerpoint/2013/main/command">
   <pc:docChgLst>
@@ -248,6 +256,60 @@
       </pc:sldChg>
     </pc:docChg>
   </pc:docChgLst>
+  <pc:docChgLst>
+    <pc:chgData clId="Web-{9F2E0053-6AD3-4BB1-B286-6F91667728FA}"/>
+    <pc:docChg chg="modSld">
+      <pc:chgData name="" userId="" providerId="" clId="Web-{9F2E0053-6AD3-4BB1-B286-6F91667728FA}" dt="2026-10-30T08:18:09.535" v="1" actId="34807"/>
+      <pc:docMkLst>
+        <pc:docMk/>
+      </pc:docMkLst>
+      <pc:sldChg chg="delSp">
+        <pc:chgData name="" userId="" providerId="" clId="Web-{9F2E0053-6AD3-4BB1-B286-6F91667728FA}" dt="2026-10-30T08:18:09.238" v="0" actId="34807"/>
+        <pc:sldMkLst>
+          <pc:docMk/>
+          <pc:sldMk cId="0" sldId="256"/>
+        </pc:sldMkLst>
+        <pc:spChg chg="del">
+          <ac:chgData name="" userId="" providerId="" clId="Web-{9F2E0053-6AD3-4BB1-B286-6F91667728FA}" dt="2026-10-30T08:18:09.238" v="0" actId="34807"/>
+          <ac:spMkLst>
+            <pc:docMk/>
+            <pc:sldMk cId="0" sldId="256"/>
+            <ac:spMk id="14" creationId="{00000000-0000-0000-0000-000000000000}"/>
+          </ac:spMkLst>
+        </pc:spChg>
+      </pc:sldChg>
+      <pc:sldChg chg="modSp">
+        <pc:chgData name="" userId="" providerId="" clId="Web-{9F2E0053-6AD3-4BB1-B286-6F91667728FA}" dt="2026-10-30T08:18:09.535" v="1" actId="34807"/>
+        <pc:sldMkLst>
+          <pc:docMk/>
+          <pc:sldMk cId="0" sldId="261"/>
+        </pc:sldMkLst>
+        <pc:spChg chg="mod">
+          <ac:chgData name="" userId="" providerId="" clId="Web-{9F2E0053-6AD3-4BB1-B286-6F91667728FA}" dt="2026-10-30T08:18:09.535" v="1" actId="34807"/>
+          <ac:spMkLst>
+            <pc:docMk/>
+            <pc:sldMk cId="0" sldId="261"/>
+            <ac:spMk id="25" creationId="{00000000-0000-0000-0000-000000000000}"/>
+          </ac:spMkLst>
+        </pc:spChg>
+      </pc:sldChg>
+      <pc:sldChg chg="modSp">
+        <pc:chgData name="" userId="" providerId="" clId="Web-{9F2E0053-6AD3-4BB1-B286-6F91667728FA}" dt="2026-10-30T08:18:09.535" v="1" actId="34807"/>
+        <pc:sldMkLst>
+          <pc:docMk/>
+          <pc:sldMk cId="0" sldId="269"/>
+        </pc:sldMkLst>
+        <pc:spChg chg="mod">
+          <ac:chgData name="" userId="" providerId="" clId="Web-{9F2E0053-6AD3-4BB1-B286-6F91667728FA}" dt="2026-10-30T08:18:09.535" v="1" actId="34807"/>
+          <ac:spMkLst>
+            <pc:docMk/>
+            <pc:sldMk cId="0" sldId="269"/>
+            <ac:spMk id="33" creationId="{00000000-0000-0000-0000-000000000000}"/>
+          </ac:spMkLst>
+        </pc:spChg>
+      </pc:sldChg>
+    </pc:docChg>
+  </pc:docChgLst>
 </pc:chgInfo>
 </file>
 
@@ -332,7 +394,7 @@
           </a:lstStyle>
           <a:p>
             <a:fld id="{20915448-D9A5-4218-8B1C-61F0674FF8C4}" type="datetimeFigureOut">
-              <a:t>10/14/2026</a:t>
+              <a:t>10/30/2026</a:t>
             </a:fld>
             <a:endParaRPr lang="en-US"/>
           </a:p>
@@ -1947,7 +2009,7 @@
           <a:p>
             <a:fld id="{5BCAD085-E8A6-8845-BD4E-CB4CCA059FC4}" type="datetimeFigureOut">
               <a:rPr lang="en-US" smtClean="0"/>
-              <a:t>10/14/2026</a:t>
+              <a:t>10/30/2026</a:t>
             </a:fld>
             <a:endParaRPr lang="en-US"/>
           </a:p>
@@ -2115,7 +2177,7 @@
           <a:p>
             <a:fld id="{5BCAD085-E8A6-8845-BD4E-CB4CCA059FC4}" type="datetimeFigureOut">
               <a:rPr lang="en-US" smtClean="0"/>
-              <a:t>10/14/2026</a:t>
+              <a:t>10/30/2026</a:t>
             </a:fld>
             <a:endParaRPr lang="en-US"/>
           </a:p>
@@ -2293,7 +2355,7 @@
           <a:p>
             <a:fld id="{5BCAD085-E8A6-8845-BD4E-CB4CCA059FC4}" type="datetimeFigureOut">
               <a:rPr lang="en-US" smtClean="0"/>
-              <a:t>10/14/2026</a:t>
+              <a:t>10/30/2026</a:t>
             </a:fld>
             <a:endParaRPr lang="en-US"/>
           </a:p>
@@ -2461,7 +2523,7 @@
           <a:p>
             <a:fld id="{5BCAD085-E8A6-8845-BD4E-CB4CCA059FC4}" type="datetimeFigureOut">
               <a:rPr lang="en-US" smtClean="0"/>
-              <a:t>10/14/2026</a:t>
+              <a:t>10/30/2026</a:t>
             </a:fld>
             <a:endParaRPr lang="en-US"/>
           </a:p>
@@ -2706,7 +2768,7 @@
           <a:p>
             <a:fld id="{5BCAD085-E8A6-8845-BD4E-CB4CCA059FC4}" type="datetimeFigureOut">
               <a:rPr lang="en-US" smtClean="0"/>
-              <a:t>10/14/2026</a:t>
+              <a:t>10/30/2026</a:t>
             </a:fld>
             <a:endParaRPr lang="en-US"/>
           </a:p>
@@ -2991,7 +3053,7 @@
           <a:p>
             <a:fld id="{5BCAD085-E8A6-8845-BD4E-CB4CCA059FC4}" type="datetimeFigureOut">
               <a:rPr lang="en-US" smtClean="0"/>
-              <a:t>10/14/2026</a:t>
+              <a:t>10/30/2026</a:t>
             </a:fld>
             <a:endParaRPr lang="en-US"/>
           </a:p>
@@ -3410,7 +3472,7 @@
           <a:p>
             <a:fld id="{5BCAD085-E8A6-8845-BD4E-CB4CCA059FC4}" type="datetimeFigureOut">
               <a:rPr lang="en-US" smtClean="0"/>
-              <a:t>10/14/2026</a:t>
+              <a:t>10/30/2026</a:t>
             </a:fld>
             <a:endParaRPr lang="en-US"/>
           </a:p>
@@ -3527,7 +3589,7 @@
           <a:p>
             <a:fld id="{5BCAD085-E8A6-8845-BD4E-CB4CCA059FC4}" type="datetimeFigureOut">
               <a:rPr lang="en-US" smtClean="0"/>
-              <a:t>10/14/2026</a:t>
+              <a:t>10/30/2026</a:t>
             </a:fld>
             <a:endParaRPr lang="en-US"/>
           </a:p>
@@ -3622,7 +3684,7 @@
           <a:p>
             <a:fld id="{5BCAD085-E8A6-8845-BD4E-CB4CCA059FC4}" type="datetimeFigureOut">
               <a:rPr lang="en-US" smtClean="0"/>
-              <a:t>10/14/2026</a:t>
+              <a:t>10/30/2026</a:t>
             </a:fld>
             <a:endParaRPr lang="en-US"/>
           </a:p>
@@ -3897,7 +3959,7 @@
           <a:p>
             <a:fld id="{5BCAD085-E8A6-8845-BD4E-CB4CCA059FC4}" type="datetimeFigureOut">
               <a:rPr lang="en-US" smtClean="0"/>
-              <a:t>10/14/2026</a:t>
+              <a:t>10/30/2026</a:t>
             </a:fld>
             <a:endParaRPr lang="en-US"/>
           </a:p>
@@ -4149,7 +4211,7 @@
           <a:p>
             <a:fld id="{5BCAD085-E8A6-8845-BD4E-CB4CCA059FC4}" type="datetimeFigureOut">
               <a:rPr lang="en-US" smtClean="0"/>
-              <a:t>10/14/2026</a:t>
+              <a:t>10/30/2026</a:t>
             </a:fld>
             <a:endParaRPr lang="en-US"/>
           </a:p>
@@ -4360,7 +4422,7 @@
           <a:p>
             <a:fld id="{5BCAD085-E8A6-8845-BD4E-CB4CCA059FC4}" type="datetimeFigureOut">
               <a:rPr lang="en-US" smtClean="0"/>
-              <a:t>10/14/2026</a:t>
+              <a:t>10/30/2026</a:t>
             </a:fld>
             <a:endParaRPr lang="en-US"/>
           </a:p>
@@ -5246,46 +5308,6 @@
       </p:sp>
       <p:sp>
         <p:nvSpPr>
-          <p:cNvPr id="14" name="TextBox 13"/>
-          <p:cNvSpPr txBox="1"/>
-          <p:nvPr/>
-        </p:nvSpPr>
-        <p:spPr>
-          <a:xfrm>
-            <a:off x="914400" y="5897880"/>
-            <a:ext cx="7315200" cy="182880"/>
-          </a:xfrm>
-          <a:prstGeom prst="rect">
-            <a:avLst/>
-          </a:prstGeom>
-          <a:noFill/>
-        </p:spPr>
-        <p:txBody>
-          <a:bodyPr wrap="square" lIns="0" tIns="0" rIns="0" bIns="0" anchor="t">
-            <a:spAutoFit/>
-          </a:bodyPr>
-          <a:lstStyle/>
-          <a:p>
-            <a:pPr algn="l">
-              <a:lnSpc>
-                <a:spcPct val="100000"/>
-              </a:lnSpc>
-            </a:pPr>
-            <a:r>
-              <a:rPr sz="950" b="0" i="0" dirty="0">
-                <a:solidFill>
-                  <a:srgbClr val="B9C2D6"/>
-                </a:solidFill>
-                <a:latin typeface="Segoe UI"/>
-                <a:cs typeface="Segoe UI"/>
-              </a:rPr>
-              <a:t>Alex Sachelarescu  ·  Cloud Solution Architect, Azure</a:t>
-            </a:r>
-          </a:p>
-        </p:txBody>
-      </p:sp>
-      <p:sp>
-        <p:nvSpPr>
           <p:cNvPr id="15" name="TextBox 14"/>
           <p:cNvSpPr txBox="1"/>
           <p:nvPr/>
@@ -15378,7 +15400,7 @@
         </p:nvSpPr>
         <p:spPr>
           <a:xfrm>
-            <a:off x="8001000" y="1371600"/>
+            <a:off x="5791200" y="1371600"/>
             <a:ext cx="6400800" cy="182880"/>
           </a:xfrm>
           <a:prstGeom prst="rect">
@@ -26020,7 +26042,7 @@
         </p:nvSpPr>
         <p:spPr>
           <a:xfrm>
-            <a:off x="5989320" y="4114800"/>
+            <a:off x="5791200" y="4114800"/>
             <a:ext cx="6400800" cy="182880"/>
           </a:xfrm>
           <a:prstGeom prst="rect">

</xml_diff>